<commit_message>
Slides: shorten every slide line of sd-01-022..026 to ten words
The decks broke the ten-words-per-line rule of docs/sd101-slides.md.
Lines are shortened in Moda and the badged PPTX files re-exported.

Co-Authored-By: Claude Opus 5.5 <noreply@anthropic.com>
Claude-Session: https://claude.ai/code/session_01PmqNRWe4NoiAuhPfHYj9Qq
</commit_message>
<xml_diff>
--- a/system-design-101/vi/lessons/sd-01-022/slides/sd-01-022.pptx
+++ b/system-design-101/vi/lessons/sd-01-022/slides/sd-01-022.pptx
@@ -1943,7 +1943,7 @@
               <a:t> thực:</a:t>
             </a:r>
             <a:r>
-              <a:rPr lang="en-US" sz="3000" dirty="0" spc="-1" kern="0">
+              <a:rPr lang="en-US" sz="3000" dirty="0" spc="1" kern="0">
                 <a:solidFill>
                   <a:srgbClr val="E4E1D8"/>
                 </a:solidFill>
@@ -1951,7 +1951,7 @@
                 <a:ea typeface="Be Vietnam Pro" pitchFamily="34" charset="-122"/>
                 <a:cs typeface="Be Vietnam Pro" pitchFamily="34" charset="-120"/>
               </a:rPr>
-              <a:t> đặt</a:t>
+              <a:t> thêm</a:t>
             </a:r>
             <a:r>
               <a:rPr lang="en-US" sz="3000" dirty="0" spc="-43" kern="0">
@@ -1963,28 +1963,6 @@
                 <a:cs typeface="Be Vietnam Pro" pitchFamily="34" charset="-120"/>
               </a:rPr>
               <a:t> gateway</a:t>
-            </a:r>
-            <a:r>
-              <a:rPr lang="en-US" sz="3000" dirty="0" spc="2" kern="0">
-                <a:solidFill>
-                  <a:srgbClr val="E4E1D8"/>
-                </a:solidFill>
-                <a:latin typeface="Be Vietnam Pro" pitchFamily="34" charset="0"/>
-                <a:ea typeface="Be Vietnam Pro" pitchFamily="34" charset="-122"/>
-                <a:cs typeface="Be Vietnam Pro" pitchFamily="34" charset="-120"/>
-              </a:rPr>
-              <a:t> phía</a:t>
-            </a:r>
-            <a:r>
-              <a:rPr lang="en-US" sz="3000" dirty="0" spc="9" kern="0">
-                <a:solidFill>
-                  <a:srgbClr val="E4E1D8"/>
-                </a:solidFill>
-                <a:latin typeface="Be Vietnam Pro" pitchFamily="34" charset="0"/>
-                <a:ea typeface="Be Vietnam Pro" pitchFamily="34" charset="-122"/>
-                <a:cs typeface="Be Vietnam Pro" pitchFamily="34" charset="-120"/>
-              </a:rPr>
-              <a:t> trước</a:t>
             </a:r>
             <a:r>
               <a:rPr lang="en-US" sz="3000" dirty="0" spc="11" kern="0">
@@ -5146,7 +5124,7 @@
               <a:t> kê,</a:t>
             </a:r>
             <a:r>
-              <a:rPr lang="en-US" sz="2700" dirty="0" spc="-30" kern="0">
+              <a:rPr lang="en-US" sz="2700" dirty="0" spc="-18" kern="0">
                 <a:solidFill>
                   <a:srgbClr val="3B3A37"/>
                 </a:solidFill>
@@ -5154,7 +5132,7 @@
                 <a:ea typeface="Be Vietnam Pro" pitchFamily="34" charset="-122"/>
                 <a:cs typeface="Be Vietnam Pro" pitchFamily="34" charset="-120"/>
               </a:rPr>
-              <a:t> rồi</a:t>
+              <a:t> và</a:t>
             </a:r>
             <a:r>
               <a:rPr lang="en-US" sz="2700" dirty="0" spc="1" kern="0">
@@ -5168,7 +5146,7 @@
               <a:t> cái</a:t>
             </a:r>
             <a:r>
-              <a:rPr lang="en-US" sz="2700" dirty="0" spc="-1" kern="0">
+              <a:rPr lang="en-US" sz="2700" dirty="0" spc="-2" kern="0">
                 <a:solidFill>
                   <a:srgbClr val="3B3A37"/>
                 </a:solidFill>
@@ -5176,29 +5154,7 @@
                 <a:ea typeface="Be Vietnam Pro" pitchFamily="34" charset="-122"/>
                 <a:cs typeface="Be Vietnam Pro" pitchFamily="34" charset="-120"/>
               </a:rPr>
-              <a:t> giá</a:t>
-            </a:r>
-            <a:r>
-              <a:rPr lang="en-US" sz="2700" dirty="0" spc="-2" kern="0">
-                <a:solidFill>
-                  <a:srgbClr val="3B3A37"/>
-                </a:solidFill>
-                <a:latin typeface="Be Vietnam Pro" pitchFamily="34" charset="0"/>
-                <a:ea typeface="Be Vietnam Pro" pitchFamily="34" charset="-122"/>
-                <a:cs typeface="Be Vietnam Pro" pitchFamily="34" charset="-120"/>
-              </a:rPr>
-              <a:t> phải</a:t>
-            </a:r>
-            <a:r>
-              <a:rPr lang="en-US" sz="2700" dirty="0" spc="-22" kern="0">
-                <a:solidFill>
-                  <a:srgbClr val="3B3A37"/>
-                </a:solidFill>
-                <a:latin typeface="Be Vietnam Pro" pitchFamily="34" charset="0"/>
-                <a:ea typeface="Be Vietnam Pro" pitchFamily="34" charset="-122"/>
-                <a:cs typeface="Be Vietnam Pro" pitchFamily="34" charset="-120"/>
-              </a:rPr>
-              <a:t> trả.</a:t>
+              <a:t> giá.</a:t>
             </a:r>
             <a:endParaRPr lang="en-US" sz="2700" dirty="0"/>
           </a:p>
@@ -7088,7 +7044,7 @@
               <a:buNone/>
             </a:pPr>
             <a:r>
-              <a:rPr lang="en-US" sz="2400" dirty="0" spc="-53" kern="0">
+              <a:rPr lang="en-US" sz="2400" dirty="0" spc="-4" kern="0">
                 <a:solidFill>
                   <a:srgbClr val="3B3A37"/>
                 </a:solidFill>
@@ -7096,7 +7052,7 @@
                 <a:ea typeface="Be Vietnam Pro" pitchFamily="34" charset="-122"/>
                 <a:cs typeface="Be Vietnam Pro" pitchFamily="34" charset="-120"/>
               </a:rPr>
-              <a:t>Tổng</a:t>
+              <a:t>Nhu</a:t>
             </a:r>
             <a:r>
               <a:rPr lang="en-US" sz="2400" dirty="0" spc="0" kern="0">
@@ -7107,10 +7063,10 @@
                 <a:ea typeface="Be Vietnam Pro" pitchFamily="34" charset="-122"/>
                 <a:cs typeface="Be Vietnam Pro" pitchFamily="34" charset="-120"/>
               </a:rPr>
-              <a:t> nhu</a:t>
-            </a:r>
-            <a:r>
-              <a:rPr lang="en-US" sz="2400" dirty="0" spc="-1" kern="0">
+              <a:t> cầu</a:t>
+            </a:r>
+            <a:r>
+              <a:rPr lang="en-US" sz="2400" dirty="0" spc="7" kern="0">
                 <a:solidFill>
                   <a:srgbClr val="3B3A37"/>
                 </a:solidFill>
@@ -7118,10 +7074,10 @@
                 <a:ea typeface="Be Vietnam Pro" pitchFamily="34" charset="-122"/>
                 <a:cs typeface="Be Vietnam Pro" pitchFamily="34" charset="-120"/>
               </a:rPr>
-              <a:t> cầu</a:t>
-            </a:r>
-            <a:r>
-              <a:rPr lang="en-US" sz="2400" dirty="0" spc="7" kern="0">
+              <a:t> vượt</a:t>
+            </a:r>
+            <a:r>
+              <a:rPr lang="en-US" sz="2400" dirty="0" spc="2" kern="0">
                 <a:solidFill>
                   <a:srgbClr val="3B3A37"/>
                 </a:solidFill>
@@ -7129,10 +7085,10 @@
                 <a:ea typeface="Be Vietnam Pro" pitchFamily="34" charset="-122"/>
                 <a:cs typeface="Be Vietnam Pro" pitchFamily="34" charset="-120"/>
               </a:rPr>
-              <a:t> vượt</a:t>
-            </a:r>
-            <a:r>
-              <a:rPr lang="en-US" sz="2400" dirty="0" spc="2" kern="0">
+              <a:t> năng</a:t>
+            </a:r>
+            <a:r>
+              <a:rPr lang="en-US" sz="2400" dirty="0" spc="10" kern="0">
                 <a:solidFill>
                   <a:srgbClr val="3B3A37"/>
                 </a:solidFill>
@@ -7140,10 +7096,10 @@
                 <a:ea typeface="Be Vietnam Pro" pitchFamily="34" charset="-122"/>
                 <a:cs typeface="Be Vietnam Pro" pitchFamily="34" charset="-120"/>
               </a:rPr>
-              <a:t> năng</a:t>
-            </a:r>
-            <a:r>
-              <a:rPr lang="en-US" sz="2400" dirty="0" spc="10" kern="0">
+              <a:t> lực</a:t>
+            </a:r>
+            <a:r>
+              <a:rPr lang="en-US" sz="2400" dirty="0" spc="1" kern="0">
                 <a:solidFill>
                   <a:srgbClr val="3B3A37"/>
                 </a:solidFill>
@@ -7151,54 +7107,32 @@
                 <a:ea typeface="Be Vietnam Pro" pitchFamily="34" charset="-122"/>
                 <a:cs typeface="Be Vietnam Pro" pitchFamily="34" charset="-120"/>
               </a:rPr>
-              <a:t> lực</a:t>
+              <a:t> thì</a:t>
+            </a:r>
+            <a:r>
+              <a:rPr lang="en-US" sz="2400" dirty="0" spc="-6" kern="0">
+                <a:solidFill>
+                  <a:srgbClr val="3B3A37"/>
+                </a:solidFill>
+                <a:latin typeface="Be Vietnam Pro" pitchFamily="34" charset="0"/>
+                <a:ea typeface="Be Vietnam Pro" pitchFamily="34" charset="-122"/>
+                <a:cs typeface="Be Vietnam Pro" pitchFamily="34" charset="-120"/>
+              </a:rPr>
+              <a:t> máy</a:t>
+            </a:r>
+            <a:r>
+              <a:rPr lang="en-US" sz="2400" dirty="0" spc="-12" kern="0">
+                <a:solidFill>
+                  <a:srgbClr val="3B3A37"/>
+                </a:solidFill>
+                <a:latin typeface="Be Vietnam Pro" pitchFamily="34" charset="0"/>
+                <a:ea typeface="Be Vietnam Pro" pitchFamily="34" charset="-122"/>
+                <a:cs typeface="Be Vietnam Pro" pitchFamily="34" charset="-120"/>
+              </a:rPr>
+              <a:t> vẫn</a:t>
             </a:r>
             <a:r>
               <a:rPr lang="en-US" sz="2400" dirty="0" spc="1" kern="0">
-                <a:solidFill>
-                  <a:srgbClr val="3B3A37"/>
-                </a:solidFill>
-                <a:latin typeface="Be Vietnam Pro" pitchFamily="34" charset="0"/>
-                <a:ea typeface="Be Vietnam Pro" pitchFamily="34" charset="-122"/>
-                <a:cs typeface="Be Vietnam Pro" pitchFamily="34" charset="-120"/>
-              </a:rPr>
-              <a:t> thì</a:t>
-            </a:r>
-            <a:r>
-              <a:rPr lang="en-US" sz="2400" dirty="0" spc="0" kern="0">
-                <a:solidFill>
-                  <a:srgbClr val="3B3A37"/>
-                </a:solidFill>
-                <a:latin typeface="Be Vietnam Pro" pitchFamily="34" charset="0"/>
-                <a:ea typeface="Be Vietnam Pro" pitchFamily="34" charset="-122"/>
-                <a:cs typeface="Be Vietnam Pro" pitchFamily="34" charset="-120"/>
-              </a:rPr>
-              <a:t> các</a:t>
-            </a:r>
-            <a:r>
-              <a:rPr lang="en-US" sz="2400" dirty="0" spc="-6" kern="0">
-                <a:solidFill>
-                  <a:srgbClr val="3B3A37"/>
-                </a:solidFill>
-                <a:latin typeface="Be Vietnam Pro" pitchFamily="34" charset="0"/>
-                <a:ea typeface="Be Vietnam Pro" pitchFamily="34" charset="-122"/>
-                <a:cs typeface="Be Vietnam Pro" pitchFamily="34" charset="-120"/>
-              </a:rPr>
-              <a:t> máy</a:t>
-            </a:r>
-            <a:r>
-              <a:rPr lang="en-US" sz="2400" dirty="0" spc="-12" kern="0">
-                <a:solidFill>
-                  <a:srgbClr val="3B3A37"/>
-                </a:solidFill>
-                <a:latin typeface="Be Vietnam Pro" pitchFamily="34" charset="0"/>
-                <a:ea typeface="Be Vietnam Pro" pitchFamily="34" charset="-122"/>
-                <a:cs typeface="Be Vietnam Pro" pitchFamily="34" charset="-120"/>
-              </a:rPr>
-              <a:t> vẫn</a:t>
-            </a:r>
-            <a:r>
-              <a:rPr lang="en-US" sz="2400" dirty="0" spc="2" kern="0">
                 <a:solidFill>
                   <a:srgbClr val="3B3A37"/>
                 </a:solidFill>
@@ -8481,7 +8415,7 @@
               <a:t> cầu</a:t>
             </a:r>
             <a:r>
-              <a:rPr lang="en-US" sz="3450" dirty="0" spc="-4" kern="0">
+              <a:rPr lang="en-US" sz="3450" dirty="0" spc="-1" kern="0">
                 <a:solidFill>
                   <a:srgbClr val="14161C"/>
                 </a:solidFill>
@@ -8489,10 +8423,10 @@
                 <a:ea typeface="Bricolage Grotesque ExtraBold" pitchFamily="34" charset="-122"/>
                 <a:cs typeface="Bricolage Grotesque ExtraBold" pitchFamily="34" charset="-120"/>
               </a:rPr>
-              <a:t> một</a:t>
-            </a:r>
-            <a:r>
-              <a:rPr lang="en-US" sz="3450" dirty="0" spc="-1" kern="0">
+              <a:t> client</a:t>
+            </a:r>
+            <a:r>
+              <a:rPr lang="en-US" sz="3450" dirty="0" spc="14" kern="0">
                 <a:solidFill>
                   <a:srgbClr val="14161C"/>
                 </a:solidFill>
@@ -8500,10 +8434,10 @@
                 <a:ea typeface="Bricolage Grotesque ExtraBold" pitchFamily="34" charset="-122"/>
                 <a:cs typeface="Bricolage Grotesque ExtraBold" pitchFamily="34" charset="-120"/>
               </a:rPr>
-              <a:t> client</a:t>
-            </a:r>
-            <a:r>
-              <a:rPr lang="en-US" sz="3450" dirty="0" spc="14" kern="0">
+              <a:t> gửi</a:t>
+            </a:r>
+            <a:r>
+              <a:rPr lang="en-US" sz="3450" dirty="0" spc="-7" kern="0">
                 <a:solidFill>
                   <a:srgbClr val="14161C"/>
                 </a:solidFill>
@@ -8511,10 +8445,10 @@
                 <a:ea typeface="Bricolage Grotesque ExtraBold" pitchFamily="34" charset="-122"/>
                 <a:cs typeface="Bricolage Grotesque ExtraBold" pitchFamily="34" charset="-120"/>
               </a:rPr>
-              <a:t> gửi</a:t>
-            </a:r>
-            <a:r>
-              <a:rPr lang="en-US" sz="3450" dirty="0" spc="-7" kern="0">
+              <a:t> trong</a:t>
+            </a:r>
+            <a:r>
+              <a:rPr lang="en-US" sz="3450" dirty="0" spc="-4" kern="0">
                 <a:solidFill>
                   <a:srgbClr val="14161C"/>
                 </a:solidFill>
@@ -8522,21 +8456,10 @@
                 <a:ea typeface="Bricolage Grotesque ExtraBold" pitchFamily="34" charset="-122"/>
                 <a:cs typeface="Bricolage Grotesque ExtraBold" pitchFamily="34" charset="-120"/>
               </a:rPr>
-              <a:t> trong</a:t>
-            </a:r>
-            <a:r>
-              <a:rPr lang="en-US" sz="3450" dirty="0" spc="-3" kern="0">
-                <a:solidFill>
-                  <a:srgbClr val="14161C"/>
-                </a:solidFill>
-                <a:latin typeface="Bricolage Grotesque ExtraBold" pitchFamily="34" charset="0"/>
-                <a:ea typeface="Bricolage Grotesque ExtraBold" pitchFamily="34" charset="-122"/>
-                <a:cs typeface="Bricolage Grotesque ExtraBold" pitchFamily="34" charset="-120"/>
-              </a:rPr>
               <a:t> một</a:t>
             </a:r>
             <a:r>
-              <a:rPr lang="en-US" sz="3450" dirty="0" spc="-2" kern="0">
+              <a:rPr lang="en-US" sz="3450" dirty="0" spc="-1" kern="0">
                 <a:solidFill>
                   <a:srgbClr val="14161C"/>
                 </a:solidFill>
@@ -9286,15 +9209,59 @@
               <a:buNone/>
             </a:pPr>
             <a:r>
-              <a:rPr lang="en-US" sz="2700" dirty="0" spc="0" kern="0">
-                <a:solidFill>
-                  <a:srgbClr val="14161C"/>
-                </a:solidFill>
-                <a:latin typeface="Be Vietnam Pro" pitchFamily="34" charset="0"/>
-                <a:ea typeface="Be Vietnam Pro" pitchFamily="34" charset="-122"/>
-                <a:cs typeface="Be Vietnam Pro" pitchFamily="34" charset="-120"/>
-              </a:rPr>
-              <a:t>Nhiều</a:t>
+              <a:rPr lang="en-US" sz="2700" dirty="0" spc="-7" kern="0">
+                <a:solidFill>
+                  <a:srgbClr val="14161C"/>
+                </a:solidFill>
+                <a:latin typeface="Be Vietnam Pro" pitchFamily="34" charset="0"/>
+                <a:ea typeface="Be Vietnam Pro" pitchFamily="34" charset="-122"/>
+                <a:cs typeface="Be Vietnam Pro" pitchFamily="34" charset="-120"/>
+              </a:rPr>
+              <a:t>Một</a:t>
+            </a:r>
+            <a:r>
+              <a:rPr lang="en-US" sz="2700" dirty="0" spc="-25" kern="0">
+                <a:solidFill>
+                  <a:srgbClr val="14161C"/>
+                </a:solidFill>
+                <a:latin typeface="Be Vietnam Pro" pitchFamily="34" charset="0"/>
+                <a:ea typeface="Be Vietnam Pro" pitchFamily="34" charset="-122"/>
+                <a:cs typeface="Be Vietnam Pro" pitchFamily="34" charset="-120"/>
+              </a:rPr>
+              <a:t> yêu</a:t>
+            </a:r>
+            <a:r>
+              <a:rPr lang="en-US" sz="2700" dirty="0" spc="1" kern="0">
+                <a:solidFill>
+                  <a:srgbClr val="14161C"/>
+                </a:solidFill>
+                <a:latin typeface="Be Vietnam Pro" pitchFamily="34" charset="0"/>
+                <a:ea typeface="Be Vietnam Pro" pitchFamily="34" charset="-122"/>
+                <a:cs typeface="Be Vietnam Pro" pitchFamily="34" charset="-120"/>
+              </a:rPr>
+              <a:t> cầu</a:t>
+            </a:r>
+            <a:r>
+              <a:rPr lang="en-US" sz="2700" dirty="0" spc="-9" kern="0">
+                <a:solidFill>
+                  <a:srgbClr val="14161C"/>
+                </a:solidFill>
+                <a:latin typeface="Be Vietnam Pro" pitchFamily="34" charset="0"/>
+                <a:ea typeface="Be Vietnam Pro" pitchFamily="34" charset="-122"/>
+                <a:cs typeface="Be Vietnam Pro" pitchFamily="34" charset="-120"/>
+              </a:rPr>
+              <a:t> thay</a:t>
+            </a:r>
+            <a:r>
+              <a:rPr lang="en-US" sz="2700" dirty="0" spc="-1" kern="0">
+                <a:solidFill>
+                  <a:srgbClr val="14161C"/>
+                </a:solidFill>
+                <a:latin typeface="Be Vietnam Pro" pitchFamily="34" charset="0"/>
+                <a:ea typeface="Be Vietnam Pro" pitchFamily="34" charset="-122"/>
+                <a:cs typeface="Be Vietnam Pro" pitchFamily="34" charset="-120"/>
+              </a:rPr>
+              <a:t> cho</a:t>
             </a:r>
             <a:r>
               <a:rPr lang="en-US" sz="2700" dirty="0" spc="-2" kern="0">
@@ -9305,6 +9272,17 @@
                 <a:ea typeface="Be Vietnam Pro" pitchFamily="34" charset="-122"/>
                 <a:cs typeface="Be Vietnam Pro" pitchFamily="34" charset="-120"/>
               </a:rPr>
+              <a:t> nhiều</a:t>
+            </a:r>
+            <a:r>
+              <a:rPr lang="en-US" sz="2700" dirty="0" spc="-1" kern="0">
+                <a:solidFill>
+                  <a:srgbClr val="14161C"/>
+                </a:solidFill>
+                <a:latin typeface="Be Vietnam Pro" pitchFamily="34" charset="0"/>
+                <a:ea typeface="Be Vietnam Pro" pitchFamily="34" charset="-122"/>
+                <a:cs typeface="Be Vietnam Pro" pitchFamily="34" charset="-120"/>
+              </a:rPr>
               <a:t> lời</a:t>
             </a:r>
             <a:r>
@@ -9330,28 +9308,6 @@
               <a:t> phía</a:t>
             </a:r>
             <a:r>
-              <a:rPr lang="en-US" sz="2700" dirty="0" spc="-9" kern="0">
-                <a:solidFill>
-                  <a:srgbClr val="14161C"/>
-                </a:solidFill>
-                <a:latin typeface="Be Vietnam Pro" pitchFamily="34" charset="0"/>
-                <a:ea typeface="Be Vietnam Pro" pitchFamily="34" charset="-122"/>
-                <a:cs typeface="Be Vietnam Pro" pitchFamily="34" charset="-120"/>
-              </a:rPr>
-              <a:t> sau</a:t>
-            </a:r>
-            <a:r>
-              <a:rPr lang="en-US" sz="2700" dirty="0" spc="0" kern="0">
-                <a:solidFill>
-                  <a:srgbClr val="14161C"/>
-                </a:solidFill>
-                <a:latin typeface="Be Vietnam Pro" pitchFamily="34" charset="0"/>
-                <a:ea typeface="Be Vietnam Pro" pitchFamily="34" charset="-122"/>
-                <a:cs typeface="Be Vietnam Pro" pitchFamily="34" charset="-120"/>
-              </a:rPr>
-              <a:t> thành</a:t>
-            </a:r>
-            <a:r>
               <a:rPr lang="en-US" sz="2700" dirty="0" spc="-8" kern="0">
                 <a:solidFill>
                   <a:srgbClr val="14161C"/>
@@ -9360,51 +9316,7 @@
                 <a:ea typeface="Be Vietnam Pro" pitchFamily="34" charset="-122"/>
                 <a:cs typeface="Be Vietnam Pro" pitchFamily="34" charset="-120"/>
               </a:rPr>
-              <a:t> một</a:t>
-            </a:r>
-            <a:r>
-              <a:rPr lang="en-US" sz="2700" dirty="0" spc="-25" kern="0">
-                <a:solidFill>
-                  <a:srgbClr val="14161C"/>
-                </a:solidFill>
-                <a:latin typeface="Be Vietnam Pro" pitchFamily="34" charset="0"/>
-                <a:ea typeface="Be Vietnam Pro" pitchFamily="34" charset="-122"/>
-                <a:cs typeface="Be Vietnam Pro" pitchFamily="34" charset="-120"/>
-              </a:rPr>
-              <a:t> yêu</a:t>
-            </a:r>
-            <a:r>
-              <a:rPr lang="en-US" sz="2700" dirty="0" spc="1" kern="0">
-                <a:solidFill>
-                  <a:srgbClr val="14161C"/>
-                </a:solidFill>
-                <a:latin typeface="Be Vietnam Pro" pitchFamily="34" charset="0"/>
-                <a:ea typeface="Be Vietnam Pro" pitchFamily="34" charset="-122"/>
-                <a:cs typeface="Be Vietnam Pro" pitchFamily="34" charset="-120"/>
-              </a:rPr>
-              <a:t> cầu</a:t>
-            </a:r>
-            <a:r>
-              <a:rPr lang="en-US" sz="2700" dirty="0" spc="-3" kern="0">
-                <a:solidFill>
-                  <a:srgbClr val="14161C"/>
-                </a:solidFill>
-                <a:latin typeface="Be Vietnam Pro" pitchFamily="34" charset="0"/>
-                <a:ea typeface="Be Vietnam Pro" pitchFamily="34" charset="-122"/>
-                <a:cs typeface="Be Vietnam Pro" pitchFamily="34" charset="-120"/>
-              </a:rPr>
-              <a:t> phía</a:t>
-            </a:r>
-            <a:r>
-              <a:rPr lang="en-US" sz="2700" dirty="0" spc="6" kern="0">
-                <a:solidFill>
-                  <a:srgbClr val="14161C"/>
-                </a:solidFill>
-                <a:latin typeface="Be Vietnam Pro" pitchFamily="34" charset="0"/>
-                <a:ea typeface="Be Vietnam Pro" pitchFamily="34" charset="-122"/>
-                <a:cs typeface="Be Vietnam Pro" pitchFamily="34" charset="-120"/>
-              </a:rPr>
-              <a:t> trước.</a:t>
+              <a:t> sau.</a:t>
             </a:r>
             <a:endParaRPr lang="en-US" sz="2700" dirty="0"/>
           </a:p>
@@ -10767,7 +10679,7 @@
               <a:t>Thêm</a:t>
             </a:r>
             <a:r>
-              <a:rPr lang="en-US" sz="7800" dirty="0" spc="-16" kern="0">
+              <a:rPr lang="en-US" sz="7800" dirty="0" spc="-1" kern="0">
                 <a:solidFill>
                   <a:srgbClr val="14161C"/>
                 </a:solidFill>
@@ -10775,10 +10687,10 @@
                 <a:ea typeface="Bricolage Grotesque ExtraBold" pitchFamily="34" charset="-122"/>
                 <a:cs typeface="Bricolage Grotesque ExtraBold" pitchFamily="34" charset="-120"/>
               </a:rPr>
-              <a:t> một</a:t>
-            </a:r>
-            <a:r>
-              <a:rPr lang="en-US" sz="7800" dirty="0" spc="-1" kern="0">
+              <a:t> chặng</a:t>
+            </a:r>
+            <a:r>
+              <a:rPr lang="en-US" sz="7800" dirty="0" spc="28" kern="0">
                 <a:solidFill>
                   <a:srgbClr val="14161C"/>
                 </a:solidFill>
@@ -10786,10 +10698,10 @@
                 <a:ea typeface="Bricolage Grotesque ExtraBold" pitchFamily="34" charset="-122"/>
                 <a:cs typeface="Bricolage Grotesque ExtraBold" pitchFamily="34" charset="-120"/>
               </a:rPr>
-              <a:t> chặng</a:t>
-            </a:r>
-            <a:r>
-              <a:rPr lang="en-US" sz="7800" dirty="0" spc="-3" kern="0">
+              <a:t> mạng;</a:t>
+            </a:r>
+            <a:r>
+              <a:rPr lang="en-US" sz="7800" dirty="0" spc="-15" kern="0">
                 <a:solidFill>
                   <a:srgbClr val="14161C"/>
                 </a:solidFill>
@@ -10797,10 +10709,10 @@
                 <a:ea typeface="Bricolage Grotesque ExtraBold" pitchFamily="34" charset="-122"/>
                 <a:cs typeface="Bricolage Grotesque ExtraBold" pitchFamily="34" charset="-120"/>
               </a:rPr>
-              <a:t> mạng.</a:t>
-            </a:r>
-            <a:r>
-              <a:rPr lang="en-US" sz="7800" dirty="0" spc="1" kern="0">
+              <a:t> một</a:t>
+            </a:r>
+            <a:r>
+              <a:rPr lang="en-US" sz="7800" dirty="0" spc="-5" kern="0">
                 <a:solidFill>
                   <a:srgbClr val="14161C"/>
                 </a:solidFill>
@@ -10808,10 +10720,10 @@
                 <a:ea typeface="Bricolage Grotesque ExtraBold" pitchFamily="34" charset="-122"/>
                 <a:cs typeface="Bricolage Grotesque ExtraBold" pitchFamily="34" charset="-120"/>
               </a:rPr>
-              <a:t> Chỉ</a:t>
-            </a:r>
-            <a:r>
-              <a:rPr lang="en-US" sz="7800" dirty="0" spc="-15" kern="0">
+              <a:t> bản</a:t>
+            </a:r>
+            <a:r>
+              <a:rPr lang="en-US" sz="7800" dirty="0" spc="1" kern="0">
                 <a:solidFill>
                   <a:srgbClr val="14161C"/>
                 </a:solidFill>
@@ -10819,10 +10731,10 @@
                 <a:ea typeface="Bricolage Grotesque ExtraBold" pitchFamily="34" charset="-122"/>
                 <a:cs typeface="Bricolage Grotesque ExtraBold" pitchFamily="34" charset="-120"/>
               </a:rPr>
-              <a:t> một</a:t>
-            </a:r>
-            <a:r>
-              <a:rPr lang="en-US" sz="7800" dirty="0" spc="-6" kern="0">
+              <a:t> chạy</a:t>
+            </a:r>
+            <a:r>
+              <a:rPr lang="en-US" sz="7800" dirty="0" spc="-2" kern="0">
                 <a:solidFill>
                   <a:srgbClr val="14161C"/>
                 </a:solidFill>
@@ -10830,10 +10742,10 @@
                 <a:ea typeface="Bricolage Grotesque ExtraBold" pitchFamily="34" charset="-122"/>
                 <a:cs typeface="Bricolage Grotesque ExtraBold" pitchFamily="34" charset="-120"/>
               </a:rPr>
-              <a:t> bản</a:t>
-            </a:r>
-            <a:r>
-              <a:rPr lang="en-US" sz="7800" dirty="0" spc="2" kern="0">
+              <a:t> là</a:t>
+            </a:r>
+            <a:r>
+              <a:rPr lang="en-US" sz="7800" dirty="0" spc="28" kern="0">
                 <a:solidFill>
                   <a:srgbClr val="14161C"/>
                 </a:solidFill>
@@ -10841,10 +10753,10 @@
                 <a:ea typeface="Bricolage Grotesque ExtraBold" pitchFamily="34" charset="-122"/>
                 <a:cs typeface="Bricolage Grotesque ExtraBold" pitchFamily="34" charset="-120"/>
               </a:rPr>
-              <a:t> chạy</a:t>
-            </a:r>
-            <a:r>
-              <a:rPr lang="en-US" sz="7800" dirty="0" spc="-24" kern="0">
+              <a:t> điểm</a:t>
+            </a:r>
+            <a:r>
+              <a:rPr lang="en-US" sz="7800" dirty="0" spc="-34" kern="0">
                 <a:solidFill>
                   <a:srgbClr val="14161C"/>
                 </a:solidFill>
@@ -10852,43 +10764,10 @@
                 <a:ea typeface="Bricolage Grotesque ExtraBold" pitchFamily="34" charset="-122"/>
                 <a:cs typeface="Bricolage Grotesque ExtraBold" pitchFamily="34" charset="-120"/>
               </a:rPr>
-              <a:t> thì</a:t>
-            </a:r>
-            <a:r>
-              <a:rPr lang="en-US" sz="7800" dirty="0" spc="-3" kern="0">
-                <a:solidFill>
-                  <a:srgbClr val="14161C"/>
-                </a:solidFill>
-                <a:latin typeface="Bricolage Grotesque ExtraBold" pitchFamily="34" charset="0"/>
-                <a:ea typeface="Bricolage Grotesque ExtraBold" pitchFamily="34" charset="-122"/>
-                <a:cs typeface="Bricolage Grotesque ExtraBold" pitchFamily="34" charset="-120"/>
-              </a:rPr>
-              <a:t> thành</a:t>
-            </a:r>
-            <a:r>
-              <a:rPr lang="en-US" sz="7800" dirty="0" spc="28" kern="0">
-                <a:solidFill>
-                  <a:srgbClr val="14161C"/>
-                </a:solidFill>
-                <a:latin typeface="Bricolage Grotesque ExtraBold" pitchFamily="34" charset="0"/>
-                <a:ea typeface="Bricolage Grotesque ExtraBold" pitchFamily="34" charset="-122"/>
-                <a:cs typeface="Bricolage Grotesque ExtraBold" pitchFamily="34" charset="-120"/>
-              </a:rPr>
-              <a:t> điểm</a:t>
-            </a:r>
-            <a:r>
-              <a:rPr lang="en-US" sz="7800" dirty="0" spc="-33" kern="0">
-                <a:solidFill>
-                  <a:srgbClr val="14161C"/>
-                </a:solidFill>
-                <a:latin typeface="Bricolage Grotesque ExtraBold" pitchFamily="34" charset="0"/>
-                <a:ea typeface="Bricolage Grotesque ExtraBold" pitchFamily="34" charset="-122"/>
-                <a:cs typeface="Bricolage Grotesque ExtraBold" pitchFamily="34" charset="-120"/>
-              </a:rPr>
               <a:t> đơn</a:t>
             </a:r>
             <a:r>
-              <a:rPr lang="en-US" sz="7800" dirty="0" spc="-6" kern="0">
+              <a:rPr lang="en-US" sz="7800" dirty="0" spc="-5" kern="0">
                 <a:solidFill>
                   <a:srgbClr val="14161C"/>
                 </a:solidFill>
@@ -13143,7 +13022,7 @@
               <a:t> thực,</a:t>
             </a:r>
             <a:r>
-              <a:rPr lang="en-US" sz="5400" dirty="0" spc="-3" kern="0">
+              <a:rPr lang="en-US" sz="5400" dirty="0" spc="-20" kern="0">
                 <a:solidFill>
                   <a:srgbClr val="14161C"/>
                 </a:solidFill>
@@ -13151,10 +13030,10 @@
                 <a:ea typeface="Bricolage Grotesque ExtraBold" pitchFamily="34" charset="-122"/>
                 <a:cs typeface="Bricolage Grotesque ExtraBold" pitchFamily="34" charset="-120"/>
               </a:rPr>
-              <a:t> tự</a:t>
-            </a:r>
-            <a:r>
-              <a:rPr lang="en-US" sz="5400" dirty="0" spc="-20" kern="0">
+              <a:t> giới</a:t>
+            </a:r>
+            <a:r>
+              <a:rPr lang="en-US" sz="5400" dirty="0" spc="-1" kern="0">
                 <a:solidFill>
                   <a:srgbClr val="14161C"/>
                 </a:solidFill>
@@ -13162,10 +13041,10 @@
                 <a:ea typeface="Bricolage Grotesque ExtraBold" pitchFamily="34" charset="-122"/>
                 <a:cs typeface="Bricolage Grotesque ExtraBold" pitchFamily="34" charset="-120"/>
               </a:rPr>
-              <a:t> giới</a:t>
-            </a:r>
-            <a:r>
-              <a:rPr lang="en-US" sz="5400" dirty="0" spc="-2" kern="0">
+              <a:t> hạn. Thêm</a:t>
+            </a:r>
+            <a:r>
+              <a:rPr lang="en-US" sz="5400" dirty="0" spc="-44" kern="0">
                 <a:solidFill>
                   <a:srgbClr val="14161C"/>
                 </a:solidFill>
@@ -13173,73 +13052,7 @@
                 <a:ea typeface="Bricolage Grotesque ExtraBold" pitchFamily="34" charset="-122"/>
                 <a:cs typeface="Bricolage Grotesque ExtraBold" pitchFamily="34" charset="-120"/>
               </a:rPr>
-              <a:t> hạn</a:t>
-            </a:r>
-            <a:r>
-              <a:rPr lang="en-US" sz="5400" dirty="0" spc="-23" kern="0">
-                <a:solidFill>
-                  <a:srgbClr val="14161C"/>
-                </a:solidFill>
-                <a:latin typeface="Bricolage Grotesque ExtraBold" pitchFamily="34" charset="0"/>
-                <a:ea typeface="Bricolage Grotesque ExtraBold" pitchFamily="34" charset="-122"/>
-                <a:cs typeface="Bricolage Grotesque ExtraBold" pitchFamily="34" charset="-120"/>
-              </a:rPr>
-              <a:t> tốc</a:t>
-            </a:r>
-            <a:r>
-              <a:rPr lang="en-US" sz="5400" dirty="0" spc="-3" kern="0">
-                <a:solidFill>
-                  <a:srgbClr val="14161C"/>
-                </a:solidFill>
-                <a:latin typeface="Bricolage Grotesque ExtraBold" pitchFamily="34" charset="0"/>
-                <a:ea typeface="Bricolage Grotesque ExtraBold" pitchFamily="34" charset="-122"/>
-                <a:cs typeface="Bricolage Grotesque ExtraBold" pitchFamily="34" charset="-120"/>
-              </a:rPr>
-              <a:t> độ.</a:t>
-            </a:r>
-            <a:r>
-              <a:rPr lang="en-US" sz="5400" dirty="0" spc="-16" kern="0">
-                <a:solidFill>
-                  <a:srgbClr val="14161C"/>
-                </a:solidFill>
-                <a:latin typeface="Bricolage Grotesque ExtraBold" pitchFamily="34" charset="0"/>
-                <a:ea typeface="Bricolage Grotesque ExtraBold" pitchFamily="34" charset="-122"/>
-                <a:cs typeface="Bricolage Grotesque ExtraBold" pitchFamily="34" charset="-120"/>
-              </a:rPr>
-              <a:t> Đặt</a:t>
-            </a:r>
-            <a:r>
-              <a:rPr lang="en-US" sz="5400" dirty="0" spc="-50" kern="0">
-                <a:solidFill>
-                  <a:srgbClr val="14161C"/>
-                </a:solidFill>
-                <a:latin typeface="Bricolage Grotesque ExtraBold" pitchFamily="34" charset="0"/>
-                <a:ea typeface="Bricolage Grotesque ExtraBold" pitchFamily="34" charset="-122"/>
-                <a:cs typeface="Bricolage Grotesque ExtraBold" pitchFamily="34" charset="-120"/>
-              </a:rPr>
-              <a:t> gateway</a:t>
-            </a:r>
-            <a:r>
-              <a:rPr lang="en-US" sz="5400" dirty="0" spc="1" kern="0">
-                <a:solidFill>
-                  <a:srgbClr val="14161C"/>
-                </a:solidFill>
-                <a:latin typeface="Bricolage Grotesque ExtraBold" pitchFamily="34" charset="0"/>
-                <a:ea typeface="Bricolage Grotesque ExtraBold" pitchFamily="34" charset="-122"/>
-                <a:cs typeface="Bricolage Grotesque ExtraBold" pitchFamily="34" charset="-120"/>
-              </a:rPr>
-              <a:t> phía</a:t>
-            </a:r>
-            <a:r>
-              <a:rPr lang="en-US" sz="5400" dirty="0" spc="-69" kern="0">
-                <a:solidFill>
-                  <a:srgbClr val="14161C"/>
-                </a:solidFill>
-                <a:latin typeface="Bricolage Grotesque ExtraBold" pitchFamily="34" charset="0"/>
-                <a:ea typeface="Bricolage Grotesque ExtraBold" pitchFamily="34" charset="-122"/>
-                <a:cs typeface="Bricolage Grotesque ExtraBold" pitchFamily="34" charset="-120"/>
-              </a:rPr>
-              <a:t> trước?</a:t>
+              <a:t> gateway?</a:t>
             </a:r>
             <a:endParaRPr lang="en-US" sz="5400" dirty="0"/>
           </a:p>
@@ -14735,17 +14548,6 @@
               <a:buNone/>
             </a:pPr>
             <a:r>
-              <a:rPr lang="en-US" sz="2550" dirty="0" spc="-2" kern="0">
-                <a:solidFill>
-                  <a:srgbClr val="14161C"/>
-                </a:solidFill>
-                <a:latin typeface="Be Vietnam Pro" pitchFamily="34" charset="0"/>
-                <a:ea typeface="Be Vietnam Pro" pitchFamily="34" charset="-122"/>
-                <a:cs typeface="Be Vietnam Pro" pitchFamily="34" charset="-120"/>
-              </a:rPr>
-              <a:t>Mục</a:t>
-            </a:r>
-            <a:r>
               <a:rPr lang="en-US" sz="2550" dirty="0" spc="2" kern="0">
                 <a:solidFill>
                   <a:srgbClr val="14161C"/>
@@ -14754,7 +14556,40 @@
                 <a:ea typeface="Be Vietnam Pro" pitchFamily="34" charset="-122"/>
                 <a:cs typeface="Be Vietnam Pro" pitchFamily="34" charset="-120"/>
               </a:rPr>
-              <a:t> tiêu</a:t>
+              <a:t>Nỗ</a:t>
+            </a:r>
+            <a:r>
+              <a:rPr lang="en-US" sz="2550" dirty="0" spc="8" kern="0">
+                <a:solidFill>
+                  <a:srgbClr val="14161C"/>
+                </a:solidFill>
+                <a:latin typeface="Be Vietnam Pro" pitchFamily="34" charset="0"/>
+                <a:ea typeface="Be Vietnam Pro" pitchFamily="34" charset="-122"/>
+                <a:cs typeface="Be Vietnam Pro" pitchFamily="34" charset="-120"/>
+              </a:rPr>
+              <a:t> lực</a:t>
+            </a:r>
+            <a:r>
+              <a:rPr lang="en-US" sz="2550" dirty="0" spc="-12" kern="0">
+                <a:solidFill>
+                  <a:srgbClr val="14161C"/>
+                </a:solidFill>
+                <a:latin typeface="Be Vietnam Pro" pitchFamily="34" charset="0"/>
+                <a:ea typeface="Be Vietnam Pro" pitchFamily="34" charset="-122"/>
+                <a:cs typeface="Be Vietnam Pro" pitchFamily="34" charset="-120"/>
+              </a:rPr>
+              <a:t> tối</a:t>
+            </a:r>
+            <a:r>
+              <a:rPr lang="en-US" sz="2550" dirty="0" spc="12" kern="0">
+                <a:solidFill>
+                  <a:srgbClr val="14161C"/>
+                </a:solidFill>
+                <a:latin typeface="Be Vietnam Pro" pitchFamily="34" charset="0"/>
+                <a:ea typeface="Be Vietnam Pro" pitchFamily="34" charset="-122"/>
+                <a:cs typeface="Be Vietnam Pro" pitchFamily="34" charset="-120"/>
+              </a:rPr>
+              <a:t> đa,</a:t>
             </a:r>
             <a:r>
               <a:rPr lang="en-US" sz="2550" dirty="0" spc="0" kern="0">
@@ -14765,65 +14600,10 @@
                 <a:ea typeface="Be Vietnam Pro" pitchFamily="34" charset="-122"/>
                 <a:cs typeface="Be Vietnam Pro" pitchFamily="34" charset="-120"/>
               </a:rPr>
-              <a:t> nỗ</a:t>
-            </a:r>
-            <a:r>
-              <a:rPr lang="en-US" sz="2550" dirty="0" spc="8" kern="0">
-                <a:solidFill>
-                  <a:srgbClr val="14161C"/>
-                </a:solidFill>
-                <a:latin typeface="Be Vietnam Pro" pitchFamily="34" charset="0"/>
-                <a:ea typeface="Be Vietnam Pro" pitchFamily="34" charset="-122"/>
-                <a:cs typeface="Be Vietnam Pro" pitchFamily="34" charset="-120"/>
-              </a:rPr>
-              <a:t> lực</a:t>
-            </a:r>
-            <a:r>
-              <a:rPr lang="en-US" sz="2550" dirty="0" spc="-13" kern="0">
-                <a:solidFill>
-                  <a:srgbClr val="14161C"/>
-                </a:solidFill>
-                <a:latin typeface="Be Vietnam Pro" pitchFamily="34" charset="0"/>
-                <a:ea typeface="Be Vietnam Pro" pitchFamily="34" charset="-122"/>
-                <a:cs typeface="Be Vietnam Pro" pitchFamily="34" charset="-120"/>
-              </a:rPr>
-              <a:t> tối</a:t>
-            </a:r>
-            <a:r>
-              <a:rPr lang="en-US" sz="2550" dirty="0" spc="12" kern="0">
-                <a:solidFill>
-                  <a:srgbClr val="14161C"/>
-                </a:solidFill>
-                <a:latin typeface="Be Vietnam Pro" pitchFamily="34" charset="0"/>
-                <a:ea typeface="Be Vietnam Pro" pitchFamily="34" charset="-122"/>
-                <a:cs typeface="Be Vietnam Pro" pitchFamily="34" charset="-120"/>
-              </a:rPr>
-              <a:t> đa,</a:t>
-            </a:r>
-            <a:r>
-              <a:rPr lang="en-US" sz="2550" dirty="0" spc="1" kern="0">
-                <a:solidFill>
-                  <a:srgbClr val="14161C"/>
-                </a:solidFill>
-                <a:latin typeface="Be Vietnam Pro" pitchFamily="34" charset="0"/>
-                <a:ea typeface="Be Vietnam Pro" pitchFamily="34" charset="-122"/>
-                <a:cs typeface="Be Vietnam Pro" pitchFamily="34" charset="-120"/>
-              </a:rPr>
-              <a:t> không</a:t>
-            </a:r>
-            <a:r>
-              <a:rPr lang="en-US" sz="2550" dirty="0" spc="-1" kern="0">
-                <a:solidFill>
-                  <a:srgbClr val="14161C"/>
-                </a:solidFill>
-                <a:latin typeface="Be Vietnam Pro" pitchFamily="34" charset="0"/>
-                <a:ea typeface="Be Vietnam Pro" pitchFamily="34" charset="-122"/>
-                <a:cs typeface="Be Vietnam Pro" pitchFamily="34" charset="-120"/>
-              </a:rPr>
-              <a:t> phải</a:t>
-            </a:r>
-            <a:r>
-              <a:rPr lang="en-US" sz="2550" dirty="0" spc="-19" kern="0">
+              <a:t> không phải</a:t>
+            </a:r>
+            <a:r>
+              <a:rPr lang="en-US" sz="2550" dirty="0" spc="-20" kern="0">
                 <a:solidFill>
                   <a:srgbClr val="14161C"/>
                 </a:solidFill>
@@ -14834,7 +14614,7 @@
               <a:t> trần</a:t>
             </a:r>
             <a:r>
-              <a:rPr lang="en-US" sz="2550" dirty="0" spc="-17" kern="0">
+              <a:rPr lang="en-US" sz="2550" dirty="0" spc="-16" kern="0">
                 <a:solidFill>
                   <a:srgbClr val="14161C"/>
                 </a:solidFill>
@@ -14845,7 +14625,7 @@
               <a:t> tuyệt</a:t>
             </a:r>
             <a:r>
-              <a:rPr lang="en-US" sz="2550" dirty="0" spc="11" kern="0">
+              <a:rPr lang="en-US" sz="2550" dirty="0" spc="10" kern="0">
                 <a:solidFill>
                   <a:srgbClr val="14161C"/>
                 </a:solidFill>
@@ -15222,29 +15002,7 @@
                 <a:ea typeface="Be Vietnam Pro" pitchFamily="34" charset="-122"/>
                 <a:cs typeface="Be Vietnam Pro" pitchFamily="34" charset="-120"/>
               </a:rPr>
-              <a:t>Bộ cân bằng phía</a:t>
-            </a:r>
-            <a:r>
-              <a:rPr lang="en-US" sz="1950" dirty="0" spc="3" kern="0">
-                <a:solidFill>
-                  <a:srgbClr val="6B6A66"/>
-                </a:solidFill>
-                <a:latin typeface="Be Vietnam Pro" pitchFamily="34" charset="0"/>
-                <a:ea typeface="Be Vietnam Pro" pitchFamily="34" charset="-122"/>
-                <a:cs typeface="Be Vietnam Pro" pitchFamily="34" charset="-120"/>
-              </a:rPr>
-              <a:t> trước</a:t>
-            </a:r>
-            <a:r>
-              <a:rPr lang="en-US" sz="1950" dirty="0" spc="-1" kern="0">
-                <a:solidFill>
-                  <a:srgbClr val="6B6A66"/>
-                </a:solidFill>
-                <a:latin typeface="Be Vietnam Pro" pitchFamily="34" charset="0"/>
-                <a:ea typeface="Be Vietnam Pro" pitchFamily="34" charset="-122"/>
-                <a:cs typeface="Be Vietnam Pro" pitchFamily="34" charset="-120"/>
-              </a:rPr>
-              <a:t> chia</a:t>
+              <a:t>Bộ cân bằng chia</a:t>
             </a:r>
             <a:r>
               <a:rPr lang="en-US" sz="1950" dirty="0" spc="-10" kern="0">

</xml_diff>

<commit_message>
Slides: question titles at 92 px on sd-01-022..026, re-export badged PPTX
Co-Authored-By: Claude Opus 5.5 <noreply@anthropic.com>
Claude-Session: https://claude.ai/code/session_01PmqNRWe4NoiAuhPfHYj9Qq
</commit_message>
<xml_diff>
--- a/system-design-101/vi/lessons/sd-01-022/slides/sd-01-022.pptx
+++ b/system-design-101/vi/lessons/sd-01-022/slides/sd-01-022.pptx
@@ -12948,7 +12948,7 @@
         <p:spPr>
           <a:xfrm>
             <a:off x="914400" y="1390650"/>
-            <a:ext cx="16459200" cy="1990725"/>
+            <a:ext cx="16459200" cy="2047875"/>
           </a:xfrm>
           <a:prstGeom prst="rect">
             <a:avLst/>
@@ -12957,17 +12957,17 @@
           <a:ln/>
         </p:spPr>
         <p:txBody>
-          <a:bodyPr wrap="square" lIns="0" tIns="34290" rIns="0" bIns="-34290" rtlCol="0" anchor="t"/>
+          <a:bodyPr wrap="square" lIns="0" tIns="43815" rIns="0" bIns="-43815" rtlCol="0" anchor="t"/>
           <a:lstStyle/>
           <a:p>
             <a:pPr algn="l" indent="0" marL="0">
               <a:lnSpc>
-                <a:spcPts val="5940"/>
+                <a:spcPts val="7590"/>
               </a:lnSpc>
               <a:buNone/>
             </a:pPr>
             <a:r>
-              <a:rPr lang="en-US" sz="5400" dirty="0" spc="0" kern="0">
+              <a:rPr lang="en-US" sz="6900" dirty="0" spc="2" kern="0">
                 <a:solidFill>
                   <a:srgbClr val="14161C"/>
                 </a:solidFill>
@@ -12978,7 +12978,7 @@
               <a:t>12</a:t>
             </a:r>
             <a:r>
-              <a:rPr lang="en-US" sz="5400" dirty="0" spc="-2" kern="0">
+              <a:rPr lang="en-US" sz="6900" dirty="0" spc="0" kern="0">
                 <a:solidFill>
                   <a:srgbClr val="14161C"/>
                 </a:solidFill>
@@ -12986,10 +12986,10 @@
                 <a:ea typeface="Bricolage Grotesque ExtraBold" pitchFamily="34" charset="-122"/>
                 <a:cs typeface="Bricolage Grotesque ExtraBold" pitchFamily="34" charset="-120"/>
               </a:rPr>
-              <a:t> dịch</a:t>
-            </a:r>
-            <a:r>
-              <a:rPr lang="en-US" sz="5400" dirty="0" spc="-3" kern="0">
+              <a:t> dịch vụ</a:t>
+            </a:r>
+            <a:r>
+              <a:rPr lang="en-US" sz="6900" dirty="0" spc="-1" kern="0">
                 <a:solidFill>
                   <a:srgbClr val="14161C"/>
                 </a:solidFill>
@@ -12997,10 +12997,10 @@
                 <a:ea typeface="Bricolage Grotesque ExtraBold" pitchFamily="34" charset="-122"/>
                 <a:cs typeface="Bricolage Grotesque ExtraBold" pitchFamily="34" charset="-120"/>
               </a:rPr>
-              <a:t> vụ tự</a:t>
-            </a:r>
-            <a:r>
-              <a:rPr lang="en-US" sz="5400" dirty="0" spc="-30" kern="0">
+              <a:t> tự</a:t>
+            </a:r>
+            <a:r>
+              <a:rPr lang="en-US" sz="6900" dirty="0" spc="-36" kern="0">
                 <a:solidFill>
                   <a:srgbClr val="14161C"/>
                 </a:solidFill>
@@ -13011,7 +13011,7 @@
               <a:t> xác</a:t>
             </a:r>
             <a:r>
-              <a:rPr lang="en-US" sz="5400" dirty="0" spc="-37" kern="0">
+              <a:rPr lang="en-US" sz="6900" dirty="0" spc="-48" kern="0">
                 <a:solidFill>
                   <a:srgbClr val="14161C"/>
                 </a:solidFill>
@@ -13022,7 +13022,7 @@
               <a:t> thực,</a:t>
             </a:r>
             <a:r>
-              <a:rPr lang="en-US" sz="5400" dirty="0" spc="-20" kern="0">
+              <a:rPr lang="en-US" sz="6900" dirty="0" spc="-25" kern="0">
                 <a:solidFill>
                   <a:srgbClr val="14161C"/>
                 </a:solidFill>
@@ -13033,7 +13033,7 @@
               <a:t> giới</a:t>
             </a:r>
             <a:r>
-              <a:rPr lang="en-US" sz="5400" dirty="0" spc="-1" kern="0">
+              <a:rPr lang="en-US" sz="6900" dirty="0" spc="2" kern="0">
                 <a:solidFill>
                   <a:srgbClr val="14161C"/>
                 </a:solidFill>
@@ -13041,10 +13041,10 @@
                 <a:ea typeface="Bricolage Grotesque ExtraBold" pitchFamily="34" charset="-122"/>
                 <a:cs typeface="Bricolage Grotesque ExtraBold" pitchFamily="34" charset="-120"/>
               </a:rPr>
-              <a:t> hạn. Thêm</a:t>
-            </a:r>
-            <a:r>
-              <a:rPr lang="en-US" sz="5400" dirty="0" spc="-44" kern="0">
+              <a:t> hạn.</a:t>
+            </a:r>
+            <a:r>
+              <a:rPr lang="en-US" sz="6900" dirty="0" spc="3" kern="0">
                 <a:solidFill>
                   <a:srgbClr val="14161C"/>
                 </a:solidFill>
@@ -13052,9 +13052,20 @@
                 <a:ea typeface="Bricolage Grotesque ExtraBold" pitchFamily="34" charset="-122"/>
                 <a:cs typeface="Bricolage Grotesque ExtraBold" pitchFamily="34" charset="-120"/>
               </a:rPr>
+              <a:t> Thêm</a:t>
+            </a:r>
+            <a:r>
+              <a:rPr lang="en-US" sz="6900" dirty="0" spc="-55" kern="0">
+                <a:solidFill>
+                  <a:srgbClr val="14161C"/>
+                </a:solidFill>
+                <a:latin typeface="Bricolage Grotesque ExtraBold" pitchFamily="34" charset="0"/>
+                <a:ea typeface="Bricolage Grotesque ExtraBold" pitchFamily="34" charset="-122"/>
+                <a:cs typeface="Bricolage Grotesque ExtraBold" pitchFamily="34" charset="-120"/>
+              </a:rPr>
               <a:t> gateway?</a:t>
             </a:r>
-            <a:endParaRPr lang="en-US" sz="5400" dirty="0"/>
+            <a:endParaRPr lang="en-US" sz="6900" dirty="0"/>
           </a:p>
         </p:txBody>
       </p:sp>
@@ -13066,12 +13077,12 @@
         </p:nvSpPr>
         <p:spPr>
           <a:xfrm>
-            <a:off x="914400" y="3619500"/>
-            <a:ext cx="8096250" cy="5334000"/>
+            <a:off x="914400" y="3810000"/>
+            <a:ext cx="8096250" cy="5143500"/>
           </a:xfrm>
           <a:prstGeom prst="roundRect">
             <a:avLst>
-              <a:gd name="adj" fmla="val 5714"/>
+              <a:gd name="adj" fmla="val 5926"/>
             </a:avLst>
           </a:prstGeom>
           <a:solidFill>
@@ -13088,7 +13099,7 @@
         </p:nvSpPr>
         <p:spPr>
           <a:xfrm>
-            <a:off x="1333500" y="3962400"/>
+            <a:off x="1333500" y="4152900"/>
             <a:ext cx="7334250" cy="457200"/>
           </a:xfrm>
           <a:prstGeom prst="rect">
@@ -13127,7 +13138,7 @@
         </p:nvSpPr>
         <p:spPr>
           <a:xfrm>
-            <a:off x="1333500" y="4476750"/>
+            <a:off x="1333500" y="4667250"/>
             <a:ext cx="7334250" cy="4000500"/>
           </a:xfrm>
           <a:prstGeom prst="rect">
@@ -13397,12 +13408,12 @@
         </p:nvSpPr>
         <p:spPr>
           <a:xfrm>
-            <a:off x="9277350" y="3619500"/>
-            <a:ext cx="8096250" cy="5334000"/>
+            <a:off x="9277350" y="3810000"/>
+            <a:ext cx="8096250" cy="5143500"/>
           </a:xfrm>
           <a:prstGeom prst="roundRect">
             <a:avLst>
-              <a:gd name="adj" fmla="val 5714"/>
+              <a:gd name="adj" fmla="val 5926"/>
             </a:avLst>
           </a:prstGeom>
           <a:solidFill>
@@ -13419,7 +13430,7 @@
         </p:nvSpPr>
         <p:spPr>
           <a:xfrm>
-            <a:off x="9696450" y="3962400"/>
+            <a:off x="9696450" y="4152900"/>
             <a:ext cx="7334250" cy="457200"/>
           </a:xfrm>
           <a:prstGeom prst="rect">
@@ -13513,7 +13524,7 @@
         </p:nvSpPr>
         <p:spPr>
           <a:xfrm>
-            <a:off x="9696450" y="4476750"/>
+            <a:off x="9696450" y="4667250"/>
             <a:ext cx="7334250" cy="4000500"/>
           </a:xfrm>
           <a:prstGeom prst="rect">

</xml_diff>

<commit_message>
Slides: slide titles at 92 px on sd-01-022 slide 3 and sd-01-024 slide 5, re-export badged PPTX
Co-Authored-By: Claude Opus 5.5 <noreply@anthropic.com>
Claude-Session: https://claude.ai/code/session_01PmqNRWe4NoiAuhPfHYj9Qq
</commit_message>
<xml_diff>
--- a/system-design-101/vi/lessons/sd-01-022/slides/sd-01-022.pptx
+++ b/system-design-101/vi/lessons/sd-01-022/slides/sd-01-022.pptx
@@ -6432,7 +6432,7 @@
         <p:spPr>
           <a:xfrm>
             <a:off x="8382000" y="1619250"/>
-            <a:ext cx="8953500" cy="1990725"/>
+            <a:ext cx="8953500" cy="2190750"/>
           </a:xfrm>
           <a:prstGeom prst="rect">
             <a:avLst/>
@@ -6441,17 +6441,17 @@
           <a:ln/>
         </p:spPr>
         <p:txBody>
-          <a:bodyPr wrap="square" lIns="0" tIns="41148" rIns="0" bIns="-41148" rtlCol="0" anchor="t"/>
+          <a:bodyPr wrap="square" lIns="0" tIns="52578" rIns="0" bIns="-52578" rtlCol="0" anchor="t"/>
           <a:lstStyle/>
           <a:p>
             <a:pPr algn="l" indent="0" marL="0">
               <a:lnSpc>
-                <a:spcPts val="5832"/>
+                <a:spcPts val="7452"/>
               </a:lnSpc>
               <a:buNone/>
             </a:pPr>
             <a:r>
-              <a:rPr lang="en-US" sz="5400" dirty="0" spc="-49" kern="0">
+              <a:rPr lang="en-US" sz="6900" dirty="0" spc="-61" kern="0">
                 <a:solidFill>
                   <a:srgbClr val="14161C"/>
                 </a:solidFill>
@@ -6462,7 +6462,7 @@
               <a:t>Gateway</a:t>
             </a:r>
             <a:r>
-              <a:rPr lang="en-US" sz="5400" dirty="0" spc="15" kern="0">
+              <a:rPr lang="en-US" sz="6900" dirty="0" spc="18" kern="0">
                 <a:solidFill>
                   <a:srgbClr val="14161C"/>
                 </a:solidFill>
@@ -6473,7 +6473,7 @@
               <a:t> đứng</a:t>
             </a:r>
             <a:r>
-              <a:rPr lang="en-US" sz="5400" dirty="0" spc="-38" kern="0">
+              <a:rPr lang="en-US" sz="6900" dirty="0" spc="-47" kern="0">
                 <a:solidFill>
                   <a:srgbClr val="14161C"/>
                 </a:solidFill>
@@ -6484,7 +6484,7 @@
               <a:t> giữa</a:t>
             </a:r>
             <a:r>
-              <a:rPr lang="en-US" sz="5400" dirty="0" spc="1" kern="0">
+              <a:rPr lang="en-US" sz="6900" dirty="0" spc="3" kern="0">
                 <a:solidFill>
                   <a:srgbClr val="14161C"/>
                 </a:solidFill>
@@ -6495,7 +6495,7 @@
               <a:t> client</a:t>
             </a:r>
             <a:r>
-              <a:rPr lang="en-US" sz="5400" dirty="0" spc="-62" kern="0">
+              <a:rPr lang="en-US" sz="6900" dirty="0" spc="-76" kern="0">
                 <a:solidFill>
                   <a:srgbClr val="14161C"/>
                 </a:solidFill>
@@ -6506,7 +6506,7 @@
               <a:t> và</a:t>
             </a:r>
             <a:r>
-              <a:rPr lang="en-US" sz="5400" dirty="0" spc="-3" kern="0">
+              <a:rPr lang="en-US" sz="6900" dirty="0" spc="-1" kern="0">
                 <a:solidFill>
                   <a:srgbClr val="14161C"/>
                 </a:solidFill>
@@ -6514,9 +6514,20 @@
                 <a:ea typeface="Bricolage Grotesque ExtraBold" pitchFamily="34" charset="-122"/>
                 <a:cs typeface="Bricolage Grotesque ExtraBold" pitchFamily="34" charset="-120"/>
               </a:rPr>
-              <a:t> máy chủ</a:t>
-            </a:r>
-            <a:endParaRPr lang="en-US" sz="5400" dirty="0"/>
+              <a:t> máy</a:t>
+            </a:r>
+            <a:r>
+              <a:rPr lang="en-US" sz="6900" dirty="0" spc="1" kern="0">
+                <a:solidFill>
+                  <a:srgbClr val="14161C"/>
+                </a:solidFill>
+                <a:latin typeface="Bricolage Grotesque ExtraBold" pitchFamily="34" charset="0"/>
+                <a:ea typeface="Bricolage Grotesque ExtraBold" pitchFamily="34" charset="-122"/>
+                <a:cs typeface="Bricolage Grotesque ExtraBold" pitchFamily="34" charset="-120"/>
+              </a:rPr>
+              <a:t> chủ</a:t>
+            </a:r>
+            <a:endParaRPr lang="en-US" sz="6900" dirty="0"/>
           </a:p>
         </p:txBody>
       </p:sp>

</xml_diff>